<commit_message>
Autonomous Agent Optimization: 2026-04-23 12:55
</commit_message>
<xml_diff>
--- a/pipeline/snapshots/missions/m_1776946704_cb9e69c0/implementation_plan.pptx
+++ b/pipeline/snapshots/missions/m_1776946704_cb9e69c0/implementation_plan.pptx
@@ -3311,7 +3311,7 @@
                 </a:solidFill>
                 <a:latin typeface="Calibri"/>
               </a:rPr>
-              <a:t>Generated 2026-04-23T12:18:36 UTC</a:t>
+              <a:t>Generated 2026-04-23T16:55:24 UTC</a:t>
             </a:r>
           </a:p>
         </p:txBody>
@@ -5920,7 +5920,7 @@
                 </a:solidFill>
                 <a:latin typeface="Calibri"/>
               </a:rPr>
-              <a:t>•  data_quality → parts.missingness: FAIL (0)</a:t>
+              <a:t>•  data_quality → parts.missingness: OK (0)</a:t>
             </a:r>
           </a:p>
         </p:txBody>
@@ -5955,7 +5955,7 @@
                 </a:solidFill>
                 <a:latin typeface="Calibri"/>
               </a:rPr>
-              <a:t>Mission m_1776946704_cb9e69c0  ·  refreshed 2026-04-23T12:18:36 UTC  ·  progress 0%</a:t>
+              <a:t>Mission m_1776946704_cb9e69c0  ·  refreshed 2026-04-23T16:55:24 UTC  ·  progress 0%</a:t>
             </a:r>
           </a:p>
         </p:txBody>

</xml_diff>